<commit_message>
Updated some things in powerpoint
</commit_message>
<xml_diff>
--- a/PowerPointAppDev.pptx
+++ b/PowerPointAppDev.pptx
@@ -286,7 +286,41 @@
       </a:defRPr>
     </a:lvl9pPr>
   </p:defaultTextStyle>
+  <p:extLst>
+    <p:ext uri="{EFAFB233-063F-42B5-8137-9DF3F51BA10A}">
+      <p15:sldGuideLst xmlns:p15="http://schemas.microsoft.com/office/powerpoint/2012/main"/>
+    </p:ext>
+  </p:extLst>
 </p:presentation>
+</file>
+
+<file path=ppt/changesInfos/changesInfo1.xml><?xml version="1.0" encoding="utf-8"?>
+<pc:chgInfo xmlns:a="http://schemas.openxmlformats.org/drawingml/2006/main" xmlns:r="http://schemas.openxmlformats.org/officeDocument/2006/relationships" xmlns:ac="http://schemas.microsoft.com/office/drawing/2013/main/command" xmlns:pc="http://schemas.microsoft.com/office/powerpoint/2013/main/command">
+  <pc:docChgLst>
+    <pc:chgData name="Audreane Deschenes" userId="23aa82a02f6ee89b" providerId="LiveId" clId="{6C83BED0-3AB7-417E-AB86-80F74B7F3F60}"/>
+    <pc:docChg chg="custSel addSld delSld modSld">
+      <pc:chgData name="Audreane Deschenes" userId="23aa82a02f6ee89b" providerId="LiveId" clId="{6C83BED0-3AB7-417E-AB86-80F74B7F3F60}" dt="2025-12-11T08:25:12.756" v="3" actId="2696"/>
+      <pc:docMkLst>
+        <pc:docMk/>
+      </pc:docMkLst>
+      <pc:sldChg chg="delSp modSp add del mod">
+        <pc:chgData name="Audreane Deschenes" userId="23aa82a02f6ee89b" providerId="LiveId" clId="{6C83BED0-3AB7-417E-AB86-80F74B7F3F60}" dt="2025-12-11T08:25:12.756" v="3" actId="2696"/>
+        <pc:sldMkLst>
+          <pc:docMk/>
+          <pc:sldMk cId="3613149469" sldId="304"/>
+        </pc:sldMkLst>
+        <pc:picChg chg="del mod">
+          <ac:chgData name="Audreane Deschenes" userId="23aa82a02f6ee89b" providerId="LiveId" clId="{6C83BED0-3AB7-417E-AB86-80F74B7F3F60}" dt="2025-12-11T08:24:54.531" v="2" actId="478"/>
+          <ac:picMkLst>
+            <pc:docMk/>
+            <pc:sldMk cId="3613149469" sldId="304"/>
+            <ac:picMk id="3" creationId="{3ADE4781-62F6-D8BE-A8B0-CB0A7A8B5084}"/>
+          </ac:picMkLst>
+        </pc:picChg>
+      </pc:sldChg>
+    </pc:docChg>
+  </pc:docChgLst>
+</pc:chgInfo>
 </file>
 
 <file path=ppt/notesMasters/notesMaster1.xml><?xml version="1.0" encoding="utf-8"?>

</xml_diff>